<commit_message>
Clean up README and add playable demo clips
- README: replace the wall-of-text "Under the hood" with a concise "How it
  works" — a Mermaid pipeline diagram, three one-line pillars (naming EasyOCR),
  and the deep engineering detail folded into a collapsible.
- Tuck the staged-safety pipeline into a collapsible, matching the manual
  commands and troubleshooting; restyle the repository map as a table.
- "See it in action": two clickable demo clips (docs/demo_classify.mp4,
  docs/demo_teleop.mp4) with poster thumbnails. Clips are 1080p, ~11/21 MB
  (well under GitHub's limit), background de-emphasised with a top "spotlight"
  blur so the monitor and robot stay sharp while people behind recede.
- Rotate the sensor-board photo upright; update the deck's hardware slide to
  present it as a portrait product shot.
</commit_message>
<xml_diff>
--- a/presentation/MagPilot_Keynote.pptx
+++ b/presentation/MagPilot_Keynote.pptx
@@ -12387,15 +12387,14 @@
         </p:nvPicPr>
         <p:blipFill>
           <a:blip r:embed="rId2"/>
-          <a:srcRect l="8000" r="8000"/>
           <a:stretch>
             <a:fillRect/>
           </a:stretch>
         </p:blipFill>
         <p:spPr>
           <a:xfrm>
-            <a:off x="0" y="0"/>
-            <a:ext cx="7680960" cy="6858000"/>
+            <a:off x="834390" y="457200"/>
+            <a:ext cx="4457700" cy="5943600"/>
           </a:xfrm>
           <a:prstGeom prst="rect">
             <a:avLst/>
@@ -12404,57 +12403,13 @@
       </p:pic>
       <p:sp>
         <p:nvSpPr>
-          <p:cNvPr id="3" name="Rectangle 2"/>
-          <p:cNvSpPr/>
-          <p:nvPr/>
-        </p:nvSpPr>
-        <p:spPr>
-          <a:xfrm>
-            <a:off x="7680960" y="0"/>
-            <a:ext cx="4510735" cy="6858000"/>
-          </a:xfrm>
-          <a:prstGeom prst="rect">
-            <a:avLst/>
-          </a:prstGeom>
-          <a:solidFill>
-            <a:srgbClr val="0A1E33"/>
-          </a:solidFill>
-          <a:ln>
-            <a:noFill/>
-          </a:ln>
-          <a:effectLst/>
-        </p:spPr>
-        <p:style>
-          <a:lnRef idx="1">
-            <a:schemeClr val="accent1"/>
-          </a:lnRef>
-          <a:fillRef idx="3">
-            <a:schemeClr val="accent1"/>
-          </a:fillRef>
-          <a:effectRef idx="2">
-            <a:schemeClr val="accent1"/>
-          </a:effectRef>
-          <a:fontRef idx="minor">
-            <a:schemeClr val="lt1"/>
-          </a:fontRef>
-        </p:style>
-        <p:txBody>
-          <a:bodyPr rtlCol="0" anchor="ctr"/>
-          <a:lstStyle/>
-          <a:p>
-            <a:pPr algn="ctr"/>
-          </a:p>
-        </p:txBody>
-      </p:sp>
-      <p:sp>
-        <p:nvSpPr>
-          <p:cNvPr id="4" name="TextBox 3"/>
+          <p:cNvPr id="3" name="TextBox 2"/>
           <p:cNvSpPr txBox="1"/>
           <p:nvPr/>
         </p:nvSpPr>
         <p:spPr>
           <a:xfrm>
-            <a:off x="8046720" y="1097280"/>
+            <a:off x="6309360" y="1463040"/>
             <a:ext cx="8229600" cy="365760"/>
           </a:xfrm>
           <a:prstGeom prst="rect">
@@ -12493,14 +12448,14 @@
       </p:sp>
       <p:sp>
         <p:nvSpPr>
-          <p:cNvPr id="5" name="TextBox 4"/>
+          <p:cNvPr id="4" name="TextBox 3"/>
           <p:cNvSpPr txBox="1"/>
           <p:nvPr/>
         </p:nvSpPr>
         <p:spPr>
           <a:xfrm>
-            <a:off x="8046720" y="1600200"/>
-            <a:ext cx="3840480" cy="3108960"/>
+            <a:off x="6309360" y="1965960"/>
+            <a:ext cx="5212080" cy="3291840"/>
           </a:xfrm>
           <a:prstGeom prst="rect">
             <a:avLst/>
@@ -12525,7 +12480,7 @@
               </a:spcAft>
             </a:pPr>
             <a:r>
-              <a:rPr sz="3000" b="1">
+              <a:rPr sz="3200" b="1">
                 <a:solidFill>
                   <a:srgbClr val="FFFFFF"/>
                 </a:solidFill>
@@ -12547,7 +12502,7 @@
               </a:spcAft>
             </a:pPr>
             <a:r>
-              <a:rPr sz="3000" b="1">
+              <a:rPr sz="3200" b="1">
                 <a:solidFill>
                   <a:srgbClr val="FFFFFF"/>
                 </a:solidFill>
@@ -12569,7 +12524,7 @@
               </a:spcAft>
             </a:pPr>
             <a:r>
-              <a:rPr sz="3000" b="1">
+              <a:rPr sz="3200" b="1">
                 <a:solidFill>
                   <a:srgbClr val="FFFFFF"/>
                 </a:solidFill>
@@ -12613,7 +12568,7 @@
               </a:spcAft>
             </a:pPr>
             <a:r>
-              <a:rPr sz="1700" b="0">
+              <a:rPr sz="1800" b="0">
                 <a:solidFill>
                   <a:srgbClr val="B9D3E8"/>
                 </a:solidFill>

</xml_diff>